<commit_message>
Raise the footwear prices in the catalog
SML Legend Low goes 165 to 350, SML Slide Elite 75 to 450, as instructed.
Replaced by position on the footwear slide rather than globally — 195 and 75
also appear as accessory prices elsewhere in the deck and must not move.

This leaves SML Crown High at 195, below both, which makes the high top the
cheapest shoe in the range and puts a rubber slide above a leather sneaker.
Left as found: the number was not part of the instruction and a price is the
owner's call, not a consistency edit.

Co-Authored-By: Claude Opus 5 <noreply@anthropic.com>
Claude-Session: https://claude.ai/code/session_01UZKjRmYvN8BVrvt6KDWorw
</commit_message>
<xml_diff>
--- a/docs/SML-2026-Brand-Catalog.pptx
+++ b/docs/SML-2026-Brand-Catalog.pptx
@@ -31386,7 +31386,7 @@
                 <a:ea typeface="Calibri Light" pitchFamily="34" charset="-122"/>
                 <a:cs typeface="Calibri Light" pitchFamily="34" charset="-120"/>
               </a:rPr>
-              <a:t>$165</a:t>
+              <a:t>$350</a:t>
             </a:r>
             <a:endParaRPr lang="en-US" sz="840" dirty="0"/>
           </a:p>
@@ -32644,7 +32644,7 @@
                 <a:ea typeface="Calibri Light" pitchFamily="34" charset="-122"/>
                 <a:cs typeface="Calibri Light" pitchFamily="34" charset="-120"/>
               </a:rPr>
-              <a:t>$75</a:t>
+              <a:t>$450</a:t>
             </a:r>
             <a:endParaRPr lang="en-US" sz="840" dirty="0"/>
           </a:p>

</xml_diff>

<commit_message>
Move the whole ladder up to match the footwear
Ten more prices across four slides, each set against what the product actually
is rather than by a multiplier.

  Tee / hoodie      $65–85      ->  $195 – $450
  Legend set        $185–210    ->  $850 – $895
  Sovereign velour  $230–255    ->  $950 – $995
  Elite performance $255–280    ->  $1,050 – $1,100
  Crown High        $195        ->  $495
  Gold chain        $95         ->  $450
  Snapback          $45         ->  $195
  Duffle            $135        ->  $650
  Wristband set     $35         ->  $150

Replaced per slide, never globally — the same figure meant different things on
different pages, and a $195 sneaker and a $195 cap are not one edit.

The site moves with it: the shop hoodie goes to $450 and the tee to $195, so
the site cannot undercut the catalog a buyer is holding.

Co-Authored-By: Claude Opus 5 <noreply@anthropic.com>
Claude-Session: https://claude.ai/code/session_01UZKjRmYvN8BVrvt6KDWorw
</commit_message>
<xml_diff>
--- a/docs/SML-2026-Brand-Catalog.pptx
+++ b/docs/SML-2026-Brand-Catalog.pptx
@@ -27097,7 +27097,7 @@
                 <a:ea typeface="Calibri Light" pitchFamily="34" charset="-122"/>
                 <a:cs typeface="Calibri Light" pitchFamily="34" charset="-120"/>
               </a:rPr>
-              <a:t>$65 – $85</a:t>
+              <a:t>$195 – $450</a:t>
             </a:r>
             <a:endParaRPr lang="en-US" sz="900" dirty="0"/>
           </a:p>
@@ -29114,7 +29114,7 @@
                 <a:ea typeface="Calibri Light" pitchFamily="34" charset="-122"/>
                 <a:cs typeface="Calibri Light" pitchFamily="34" charset="-120"/>
               </a:rPr>
-              <a:t>$185 – $210</a:t>
+              <a:t>$850 – $895</a:t>
             </a:r>
             <a:endParaRPr lang="en-US" sz="1010" dirty="0"/>
           </a:p>
@@ -29451,7 +29451,7 @@
                 <a:ea typeface="Calibri Light" pitchFamily="34" charset="-122"/>
                 <a:cs typeface="Calibri Light" pitchFamily="34" charset="-120"/>
               </a:rPr>
-              <a:t>$230 – $255</a:t>
+              <a:t>$950 – $995</a:t>
             </a:r>
             <a:endParaRPr lang="en-US" sz="1010" dirty="0"/>
           </a:p>
@@ -29788,7 +29788,7 @@
                 <a:ea typeface="Calibri Light" pitchFamily="34" charset="-122"/>
                 <a:cs typeface="Calibri Light" pitchFamily="34" charset="-120"/>
               </a:rPr>
-              <a:t>$255 – $280</a:t>
+              <a:t>$1,050 – $1,100</a:t>
             </a:r>
             <a:endParaRPr lang="en-US" sz="1010" dirty="0"/>
           </a:p>
@@ -32014,7 +32014,7 @@
                 <a:ea typeface="Calibri Light" pitchFamily="34" charset="-122"/>
                 <a:cs typeface="Calibri Light" pitchFamily="34" charset="-120"/>
               </a:rPr>
-              <a:t>$195</a:t>
+              <a:t>$495</a:t>
             </a:r>
             <a:endParaRPr lang="en-US" sz="840" dirty="0"/>
           </a:p>
@@ -34485,7 +34485,7 @@
                 <a:ea typeface="Calibri Light" pitchFamily="34" charset="-122"/>
                 <a:cs typeface="Calibri Light" pitchFamily="34" charset="-120"/>
               </a:rPr>
-              <a:t>$95</a:t>
+              <a:t>$450</a:t>
             </a:r>
             <a:endParaRPr lang="en-US" sz="1690" dirty="0"/>
           </a:p>
@@ -35237,7 +35237,7 @@
                 <a:ea typeface="Calibri Light" pitchFamily="34" charset="-122"/>
                 <a:cs typeface="Calibri Light" pitchFamily="34" charset="-120"/>
               </a:rPr>
-              <a:t>$45</a:t>
+              <a:t>$195</a:t>
             </a:r>
             <a:endParaRPr lang="en-US" sz="1690" dirty="0"/>
           </a:p>
@@ -35989,7 +35989,7 @@
                 <a:ea typeface="Calibri Light" pitchFamily="34" charset="-122"/>
                 <a:cs typeface="Calibri Light" pitchFamily="34" charset="-120"/>
               </a:rPr>
-              <a:t>$135</a:t>
+              <a:t>$650</a:t>
             </a:r>
             <a:endParaRPr lang="en-US" sz="1690" dirty="0"/>
           </a:p>
@@ -36741,7 +36741,7 @@
                 <a:ea typeface="Calibri Light" pitchFamily="34" charset="-122"/>
                 <a:cs typeface="Calibri Light" pitchFamily="34" charset="-120"/>
               </a:rPr>
-              <a:t>$35</a:t>
+              <a:t>$150</a:t>
             </a:r>
             <a:endParaRPr lang="en-US" sz="1690" dirty="0"/>
           </a:p>
@@ -37413,7 +37413,7 @@
                 <a:ea typeface="Calibri Light" pitchFamily="34" charset="-122"/>
                 <a:cs typeface="Calibri Light" pitchFamily="34" charset="-120"/>
               </a:rPr>
-              <a:t>$35 — $135</a:t>
+              <a:t>$150 — $650</a:t>
             </a:r>
             <a:endParaRPr lang="en-US" sz="900" dirty="0"/>
           </a:p>

</xml_diff>